<commit_message>
sd-02-029/032: only the commit log is an append; deck keeps the source's tool order
Co-Authored-By: Claude Opus 5.5 <noreply@anthropic.com>
Claude-Session: https://claude.ai/code/session_01McBLtMnJbTnB94NeVs8a2V
</commit_message>
<xml_diff>
--- a/system-design-101/vi/lessons/sd-02-032/slides/sd-02-032.pptx
+++ b/system-design-101/vi/lessons/sd-02-032/slides/sd-02-032.pptx
@@ -9802,7 +9802,7 @@
                         <a:buNone/>
                       </a:pPr>
                       <a:r>
-                        <a:rPr lang="en-US" sz="2400" dirty="0" spc="-11" kern="0">
+                        <a:rPr lang="en-US" sz="2400" dirty="0" spc="-1" kern="0">
                           <a:solidFill>
                             <a:srgbClr val="14161C"/>
                           </a:solidFill>
@@ -9810,18 +9810,7 @@
                           <a:ea typeface="Be Vietnam Pro" pitchFamily="34" charset="-122"/>
                           <a:cs typeface="Be Vietnam Pro" pitchFamily="34" charset="-120"/>
                         </a:rPr>
-                        <a:t>Spinnaker,</a:t>
-                      </a:r>
-                      <a:r>
-                        <a:rPr lang="en-US" sz="2400" dirty="0" spc="0" kern="0">
-                          <a:solidFill>
-                            <a:srgbClr val="14161C"/>
-                          </a:solidFill>
-                          <a:latin typeface="Be Vietnam Pro" pitchFamily="34" charset="0"/>
-                          <a:ea typeface="Be Vietnam Pro" pitchFamily="34" charset="-122"/>
-                          <a:cs typeface="Be Vietnam Pro" pitchFamily="34" charset="-120"/>
-                        </a:rPr>
-                        <a:t> Chaos</a:t>
+                        <a:t>Chaos</a:t>
                       </a:r>
                       <a:r>
                         <a:rPr lang="en-US" sz="2400" dirty="0" spc="-24" kern="0">
@@ -9835,7 +9824,18 @@
                         <a:t> Monkey,</a:t>
                       </a:r>
                       <a:r>
-                        <a:rPr lang="en-US" sz="2400" dirty="0" spc="-3" kern="0">
+                        <a:rPr lang="en-US" sz="2400" dirty="0" spc="-9" kern="0">
+                          <a:solidFill>
+                            <a:srgbClr val="14161C"/>
+                          </a:solidFill>
+                          <a:latin typeface="Be Vietnam Pro" pitchFamily="34" charset="0"/>
+                          <a:ea typeface="Be Vietnam Pro" pitchFamily="34" charset="-122"/>
+                          <a:cs typeface="Be Vietnam Pro" pitchFamily="34" charset="-120"/>
+                        </a:rPr>
+                        <a:t> Spinnaker,</a:t>
+                      </a:r>
+                      <a:r>
+                        <a:rPr lang="en-US" sz="2400" dirty="0" spc="-4" kern="0">
                           <a:solidFill>
                             <a:srgbClr val="14161C"/>
                           </a:solidFill>

</xml_diff>

<commit_message>
sd-02-032: add the editor's 'who notices a failure' analysis on top of the source list
Co-Authored-By: Claude Opus 5.5 <noreply@anthropic.com>
Claude-Session: https://claude.ai/code/session_01McBLtMnJbTnB94NeVs8a2V
</commit_message>
<xml_diff>
--- a/system-design-101/vi/lessons/sd-02-032/slides/sd-02-032.pptx
+++ b/system-design-101/vi/lessons/sd-02-032/slides/sd-02-032.pptx
@@ -1884,7 +1884,7 @@
               <a:buNone/>
             </a:pPr>
             <a:r>
-              <a:rPr lang="en-US" sz="3000" dirty="0" spc="-90" kern="0">
+              <a:rPr lang="en-US" sz="3000" dirty="0" spc="2" kern="0">
                 <a:solidFill>
                   <a:srgbClr val="E4E1D8"/>
                 </a:solidFill>
@@ -1892,7 +1892,7 @@
                 <a:ea typeface="Be Vietnam Pro" pitchFamily="34" charset="-122"/>
                 <a:cs typeface="Be Vietnam Pro" pitchFamily="34" charset="-120"/>
               </a:rPr>
-              <a:t>Tám</a:t>
+              <a:t>Hỏng</a:t>
             </a:r>
             <a:r>
               <a:rPr lang="en-US" sz="3000" dirty="0" spc="0" kern="0">
@@ -1903,10 +1903,10 @@
                 <a:ea typeface="Be Vietnam Pro" pitchFamily="34" charset="-122"/>
                 <a:cs typeface="Be Vietnam Pro" pitchFamily="34" charset="-120"/>
               </a:rPr>
-              <a:t> mảng</a:t>
-            </a:r>
-            <a:r>
-              <a:rPr lang="en-US" sz="3000" dirty="0" spc="-11" kern="0">
+              <a:t> thì</a:t>
+            </a:r>
+            <a:r>
+              <a:rPr lang="en-US" sz="3000" dirty="0" spc="10" kern="0">
                 <a:solidFill>
                   <a:srgbClr val="E4E1D8"/>
                 </a:solidFill>
@@ -1914,10 +1914,10 @@
                 <a:ea typeface="Be Vietnam Pro" pitchFamily="34" charset="-122"/>
                 <a:cs typeface="Be Vietnam Pro" pitchFamily="34" charset="-120"/>
               </a:rPr>
-              <a:t> gồm</a:t>
-            </a:r>
-            <a:r>
-              <a:rPr lang="en-US" sz="3000" dirty="0" spc="19" kern="0">
+              <a:t> người</a:t>
+            </a:r>
+            <a:r>
+              <a:rPr lang="en-US" sz="3000" dirty="0" spc="-22" kern="0">
                 <a:solidFill>
                   <a:srgbClr val="E4E1D8"/>
                 </a:solidFill>
@@ -1925,10 +1925,10 @@
                 <a:ea typeface="Be Vietnam Pro" pitchFamily="34" charset="-122"/>
                 <a:cs typeface="Be Vietnam Pro" pitchFamily="34" charset="-120"/>
               </a:rPr>
-              <a:t> những</a:t>
-            </a:r>
-            <a:r>
-              <a:rPr lang="en-US" sz="3000" dirty="0" spc="1" kern="0">
+              <a:t> xem</a:t>
+            </a:r>
+            <a:r>
+              <a:rPr lang="en-US" sz="3000" dirty="0" spc="-10" kern="0">
                 <a:solidFill>
                   <a:srgbClr val="E4E1D8"/>
                 </a:solidFill>
@@ -1936,7 +1936,18 @@
                 <a:ea typeface="Be Vietnam Pro" pitchFamily="34" charset="-122"/>
                 <a:cs typeface="Be Vietnam Pro" pitchFamily="34" charset="-120"/>
               </a:rPr>
-              <a:t> công cụ</a:t>
+              <a:t> thấy</a:t>
+            </a:r>
+            <a:r>
+              <a:rPr lang="en-US" sz="3000" dirty="0" spc="2" kern="0">
+                <a:solidFill>
+                  <a:srgbClr val="E4E1D8"/>
+                </a:solidFill>
+                <a:latin typeface="Be Vietnam Pro" pitchFamily="34" charset="0"/>
+                <a:ea typeface="Be Vietnam Pro" pitchFamily="34" charset="-122"/>
+                <a:cs typeface="Be Vietnam Pro" pitchFamily="34" charset="-120"/>
+              </a:rPr>
+              <a:t> khi</a:t>
             </a:r>
             <a:r>
               <a:rPr lang="en-US" sz="3000" dirty="0" spc="-2" kern="0">
@@ -2022,10 +2033,10 @@
                 <a:ea typeface="Be Vietnam Pro" pitchFamily="34" charset="-122"/>
                 <a:cs typeface="Be Vietnam Pro" pitchFamily="34" charset="-120"/>
               </a:rPr>
-              <a:t> mảng, từ</a:t>
-            </a:r>
-            <a:r>
-              <a:rPr lang="en-US" sz="2100" dirty="0" spc="22" kern="0">
+              <a:t> mảng của</a:t>
+            </a:r>
+            <a:r>
+              <a:rPr lang="en-US" sz="2100" dirty="0" spc="0" kern="0">
                 <a:solidFill>
                   <a:srgbClr val="9AA0B5"/>
                 </a:solidFill>
@@ -2033,7 +2044,29 @@
                 <a:ea typeface="Be Vietnam Pro" pitchFamily="34" charset="-122"/>
                 <a:cs typeface="Be Vietnam Pro" pitchFamily="34" charset="-120"/>
               </a:rPr>
-              <a:t> ứng</a:t>
+              <a:t> nguồn,</a:t>
+            </a:r>
+            <a:r>
+              <a:rPr lang="en-US" sz="2100" dirty="0" spc="-9" kern="0">
+                <a:solidFill>
+                  <a:srgbClr val="9AA0B5"/>
+                </a:solidFill>
+                <a:latin typeface="Be Vietnam Pro" pitchFamily="34" charset="0"/>
+                <a:ea typeface="Be Vietnam Pro" pitchFamily="34" charset="-122"/>
+                <a:cs typeface="Be Vietnam Pro" pitchFamily="34" charset="-120"/>
+              </a:rPr>
+              <a:t> một</a:t>
+            </a:r>
+            <a:r>
+              <a:rPr lang="en-US" sz="2100" dirty="0" spc="-2" kern="0">
+                <a:solidFill>
+                  <a:srgbClr val="9AA0B5"/>
+                </a:solidFill>
+                <a:latin typeface="Be Vietnam Pro" pitchFamily="34" charset="0"/>
+                <a:ea typeface="Be Vietnam Pro" pitchFamily="34" charset="-122"/>
+                <a:cs typeface="Be Vietnam Pro" pitchFamily="34" charset="-120"/>
+              </a:rPr>
+              <a:t> phép</a:t>
             </a:r>
             <a:r>
               <a:rPr lang="en-US" sz="2100" dirty="0" spc="-1" kern="0">
@@ -2044,10 +2077,10 @@
                 <a:ea typeface="Be Vietnam Pro" pitchFamily="34" charset="-122"/>
                 <a:cs typeface="Be Vietnam Pro" pitchFamily="34" charset="-120"/>
               </a:rPr>
-              <a:t> dụng</a:t>
-            </a:r>
-            <a:r>
-              <a:rPr lang="en-US" sz="2100" dirty="0" spc="-12" kern="0">
+              <a:t> thử của</a:t>
+            </a:r>
+            <a:r>
+              <a:rPr lang="en-US" sz="2100" dirty="0" spc="-5" kern="0">
                 <a:solidFill>
                   <a:srgbClr val="9AA0B5"/>
                 </a:solidFill>
@@ -2055,10 +2088,10 @@
                 <a:ea typeface="Be Vietnam Pro" pitchFamily="34" charset="-122"/>
                 <a:cs typeface="Be Vietnam Pro" pitchFamily="34" charset="-120"/>
               </a:rPr>
-              <a:t> tới phát</a:t>
-            </a:r>
-            <a:r>
-              <a:rPr lang="en-US" sz="2100" dirty="0" spc="-1" kern="0">
+              <a:t> bài</a:t>
+            </a:r>
+            <a:r>
+              <a:rPr lang="en-US" sz="2100" dirty="0" spc="-7" kern="0">
                 <a:solidFill>
                   <a:srgbClr val="9AA0B5"/>
                 </a:solidFill>
@@ -2066,7 +2099,7 @@
                 <a:ea typeface="Be Vietnam Pro" pitchFamily="34" charset="-122"/>
                 <a:cs typeface="Be Vietnam Pro" pitchFamily="34" charset="-120"/>
               </a:rPr>
-              <a:t> hành.</a:t>
+              <a:t> này.</a:t>
             </a:r>
             <a:endParaRPr lang="en-US" sz="2100" dirty="0"/>
           </a:p>
@@ -11390,7 +11423,7 @@
               <a:buNone/>
             </a:pPr>
             <a:r>
-              <a:rPr lang="en-US" sz="6900" dirty="0" spc="-4" kern="0">
+              <a:rPr lang="en-US" sz="6900" dirty="0" spc="-32" kern="0">
                 <a:solidFill>
                   <a:srgbClr val="14161C"/>
                 </a:solidFill>
@@ -11398,10 +11431,10 @@
                 <a:ea typeface="Bricolage Grotesque ExtraBold" pitchFamily="34" charset="-122"/>
                 <a:cs typeface="Bricolage Grotesque ExtraBold" pitchFamily="34" charset="-120"/>
               </a:rPr>
-              <a:t>Bấm</a:t>
-            </a:r>
-            <a:r>
-              <a:rPr lang="en-US" sz="6900" dirty="0" spc="-79" kern="0">
+              <a:t>EVCache</a:t>
+            </a:r>
+            <a:r>
+              <a:rPr lang="en-US" sz="6900" dirty="0" spc="7" kern="0">
                 <a:solidFill>
                   <a:srgbClr val="14161C"/>
                 </a:solidFill>
@@ -11409,10 +11442,10 @@
                 <a:ea typeface="Bricolage Grotesque ExtraBold" pitchFamily="34" charset="-122"/>
                 <a:cs typeface="Bricolage Grotesque ExtraBold" pitchFamily="34" charset="-120"/>
               </a:rPr>
-              <a:t> xem</a:t>
-            </a:r>
-            <a:r>
-              <a:rPr lang="en-US" sz="6900" dirty="0" spc="2" kern="0">
+              <a:t> tắt:</a:t>
+            </a:r>
+            <a:r>
+              <a:rPr lang="en-US" sz="6900" dirty="0" spc="-66" kern="0">
                 <a:solidFill>
                   <a:srgbClr val="14161C"/>
                 </a:solidFill>
@@ -11420,10 +11453,32 @@
                 <a:ea typeface="Bricolage Grotesque ExtraBold" pitchFamily="34" charset="-122"/>
                 <a:cs typeface="Bricolage Grotesque ExtraBold" pitchFamily="34" charset="-120"/>
               </a:rPr>
-              <a:t> phim: nguồn nói</a:t>
-            </a:r>
-            <a:r>
-              <a:rPr lang="en-US" sz="6900" dirty="0" spc="-22" kern="0">
+              <a:t> người</a:t>
+            </a:r>
+            <a:r>
+              <a:rPr lang="en-US" sz="6900" dirty="0" spc="-79" kern="0">
+                <a:solidFill>
+                  <a:srgbClr val="14161C"/>
+                </a:solidFill>
+                <a:latin typeface="Bricolage Grotesque ExtraBold" pitchFamily="34" charset="0"/>
+                <a:ea typeface="Bricolage Grotesque ExtraBold" pitchFamily="34" charset="-122"/>
+                <a:cs typeface="Bricolage Grotesque ExtraBold" pitchFamily="34" charset="-120"/>
+              </a:rPr>
+              <a:t> xem</a:t>
+            </a:r>
+            <a:r>
+              <a:rPr lang="en-US" sz="6900" dirty="0" spc="-1" kern="0">
+                <a:solidFill>
+                  <a:srgbClr val="14161C"/>
+                </a:solidFill>
+                <a:latin typeface="Bricolage Grotesque ExtraBold" pitchFamily="34" charset="0"/>
+                <a:ea typeface="Bricolage Grotesque ExtraBold" pitchFamily="34" charset="-122"/>
+                <a:cs typeface="Bricolage Grotesque ExtraBold" pitchFamily="34" charset="-120"/>
+              </a:rPr>
+              <a:t> thấy</a:t>
+            </a:r>
+            <a:r>
+              <a:rPr lang="en-US" sz="6900" dirty="0" spc="-21" kern="0">
                 <a:solidFill>
                   <a:srgbClr val="14161C"/>
                 </a:solidFill>
@@ -11484,7 +11539,7 @@
               <a:buNone/>
             </a:pPr>
             <a:r>
-              <a:rPr lang="en-US" sz="1950" b="1" spc="218" kern="0" dirty="0">
+              <a:rPr lang="en-US" sz="1950" b="1" spc="224" kern="0" dirty="0">
                 <a:solidFill>
                   <a:srgbClr val="F3DFB8"/>
                 </a:solidFill>
@@ -11492,10 +11547,10 @@
                 <a:ea typeface="Be Vietnam Pro" pitchFamily="34" charset="-122"/>
                 <a:cs typeface="Be Vietnam Pro" pitchFamily="34" charset="-120"/>
               </a:rPr>
-              <a:t>BÀI</a:t>
-            </a:r>
-            <a:r>
-              <a:rPr lang="en-US" sz="1950" b="1" spc="225" kern="0" dirty="0">
+              <a:t>PHÉP</a:t>
+            </a:r>
+            <a:r>
+              <a:rPr lang="en-US" sz="1950" b="1" spc="227" kern="0" dirty="0">
                 <a:solidFill>
                   <a:srgbClr val="F3DFB8"/>
                 </a:solidFill>
@@ -11503,7 +11558,7 @@
                 <a:ea typeface="Be Vietnam Pro" pitchFamily="34" charset="-122"/>
                 <a:cs typeface="Be Vietnam Pro" pitchFamily="34" charset="-120"/>
               </a:rPr>
-              <a:t> NGUỒN</a:t>
+              <a:t> THỬ</a:t>
             </a:r>
             <a:endParaRPr lang="en-US" sz="1950" dirty="0"/>
           </a:p>
@@ -11537,7 +11592,7 @@
               <a:buNone/>
             </a:pPr>
             <a:r>
-              <a:rPr lang="en-US" sz="3450" dirty="0" spc="2" kern="0">
+              <a:rPr lang="en-US" sz="3450" dirty="0" spc="0" kern="0">
                 <a:solidFill>
                   <a:srgbClr val="F3EEE3"/>
                 </a:solidFill>
@@ -11545,10 +11600,10 @@
                 <a:ea typeface="Bricolage Grotesque ExtraBold" pitchFamily="34" charset="-122"/>
                 <a:cs typeface="Bricolage Grotesque ExtraBold" pitchFamily="34" charset="-120"/>
               </a:rPr>
-              <a:t>Chỉ</a:t>
-            </a:r>
-            <a:r>
-              <a:rPr lang="en-US" sz="3450" dirty="0" spc="1" kern="0">
+              <a:t>Hỏng</a:t>
+            </a:r>
+            <a:r>
+              <a:rPr lang="en-US" sz="3450" dirty="0" spc="-12" kern="0">
                 <a:solidFill>
                   <a:srgbClr val="F3EEE3"/>
                 </a:solidFill>
@@ -11556,10 +11611,10 @@
                 <a:ea typeface="Bricolage Grotesque ExtraBold" pitchFamily="34" charset="-122"/>
                 <a:cs typeface="Bricolage Grotesque ExtraBold" pitchFamily="34" charset="-120"/>
               </a:rPr>
-              <a:t> có</a:t>
-            </a:r>
-            <a:r>
-              <a:rPr lang="en-US" sz="3450" dirty="0" spc="-11" kern="0">
+              <a:t> thì</a:t>
+            </a:r>
+            <a:r>
+              <a:rPr lang="en-US" sz="3450" dirty="0" spc="-2" kern="0">
                 <a:solidFill>
                   <a:srgbClr val="F3EEE3"/>
                 </a:solidFill>
@@ -11567,10 +11622,10 @@
                 <a:ea typeface="Bricolage Grotesque ExtraBold" pitchFamily="34" charset="-122"/>
                 <a:cs typeface="Bricolage Grotesque ExtraBold" pitchFamily="34" charset="-120"/>
               </a:rPr>
-              <a:t> tên</a:t>
-            </a:r>
-            <a:r>
-              <a:rPr lang="en-US" sz="3450" dirty="0" spc="1" kern="0">
+              <a:t> ai</a:t>
+            </a:r>
+            <a:r>
+              <a:rPr lang="en-US" sz="3450" dirty="0" spc="-4" kern="0">
                 <a:solidFill>
                   <a:srgbClr val="F3EEE3"/>
                 </a:solidFill>
@@ -11578,7 +11633,29 @@
                 <a:ea typeface="Bricolage Grotesque ExtraBold" pitchFamily="34" charset="-122"/>
                 <a:cs typeface="Bricolage Grotesque ExtraBold" pitchFamily="34" charset="-120"/>
               </a:rPr>
-              <a:t> theo mảng</a:t>
+              <a:t> thấy,</a:t>
+            </a:r>
+            <a:r>
+              <a:rPr lang="en-US" sz="3450" dirty="0" spc="0" kern="0">
+                <a:solidFill>
+                  <a:srgbClr val="F3EEE3"/>
+                </a:solidFill>
+                <a:latin typeface="Bricolage Grotesque ExtraBold" pitchFamily="34" charset="0"/>
+                <a:ea typeface="Bricolage Grotesque ExtraBold" pitchFamily="34" charset="-122"/>
+                <a:cs typeface="Bricolage Grotesque ExtraBold" pitchFamily="34" charset="-120"/>
+              </a:rPr>
+              <a:t> khi</a:t>
+            </a:r>
+            <a:r>
+              <a:rPr lang="en-US" sz="3450" dirty="0" spc="-17" kern="0">
+                <a:solidFill>
+                  <a:srgbClr val="F3EEE3"/>
+                </a:solidFill>
+                <a:latin typeface="Bricolage Grotesque ExtraBold" pitchFamily="34" charset="0"/>
+                <a:ea typeface="Bricolage Grotesque ExtraBold" pitchFamily="34" charset="-122"/>
+                <a:cs typeface="Bricolage Grotesque ExtraBold" pitchFamily="34" charset="-120"/>
+              </a:rPr>
+              <a:t> nào?</a:t>
             </a:r>
             <a:endParaRPr lang="en-US" sz="3450" dirty="0"/>
           </a:p>
@@ -11636,7 +11713,7 @@
               <a:buNone/>
             </a:pPr>
             <a:r>
-              <a:rPr lang="en-US" sz="1800" b="1" spc="256" kern="0" dirty="0">
+              <a:rPr lang="en-US" sz="1800" b="1" spc="182" kern="0" dirty="0">
                 <a:solidFill>
                   <a:srgbClr val="B45309"/>
                 </a:solidFill>
@@ -11644,10 +11721,10 @@
                 <a:ea typeface="Be Vietnam Pro" pitchFamily="34" charset="-122"/>
                 <a:cs typeface="Be Vietnam Pro" pitchFamily="34" charset="-120"/>
               </a:rPr>
-              <a:t>ỨNG</a:t>
-            </a:r>
-            <a:r>
-              <a:rPr lang="en-US" sz="1800" b="1" spc="226" kern="0" dirty="0">
+              <a:t>THẤY</a:t>
+            </a:r>
+            <a:r>
+              <a:rPr lang="en-US" sz="1800" b="1" spc="189" kern="0" dirty="0">
                 <a:solidFill>
                   <a:srgbClr val="B45309"/>
                 </a:solidFill>
@@ -11655,29 +11732,7 @@
                 <a:ea typeface="Be Vietnam Pro" pitchFamily="34" charset="-122"/>
                 <a:cs typeface="Be Vietnam Pro" pitchFamily="34" charset="-120"/>
               </a:rPr>
-              <a:t> DỤNG</a:t>
-            </a:r>
-            <a:r>
-              <a:rPr lang="en-US" sz="1800" b="1" spc="225" kern="0" dirty="0">
-                <a:solidFill>
-                  <a:srgbClr val="B45309"/>
-                </a:solidFill>
-                <a:latin typeface="Be Vietnam Pro" pitchFamily="34" charset="0"/>
-                <a:ea typeface="Be Vietnam Pro" pitchFamily="34" charset="-122"/>
-                <a:cs typeface="Be Vietnam Pro" pitchFamily="34" charset="-120"/>
-              </a:rPr>
-              <a:t> ·</a:t>
-            </a:r>
-            <a:r>
-              <a:rPr lang="en-US" sz="1800" b="1" spc="223" kern="0" dirty="0">
-                <a:solidFill>
-                  <a:srgbClr val="B45309"/>
-                </a:solidFill>
-                <a:latin typeface="Be Vietnam Pro" pitchFamily="34" charset="0"/>
-                <a:ea typeface="Be Vietnam Pro" pitchFamily="34" charset="-122"/>
-                <a:cs typeface="Be Vietnam Pro" pitchFamily="34" charset="-120"/>
-              </a:rPr>
-              <a:t> GRAPHQL</a:t>
+              <a:t> NGAY</a:t>
             </a:r>
             <a:endParaRPr lang="en-US" sz="1800" dirty="0"/>
           </a:p>
@@ -11708,7 +11763,7 @@
               <a:buNone/>
             </a:pPr>
             <a:r>
-              <a:rPr lang="en-US" sz="3000" dirty="0" spc="4" kern="0">
+              <a:rPr lang="en-US" sz="3000" dirty="0" spc="-2" kern="0">
                 <a:solidFill>
                   <a:srgbClr val="14161C"/>
                 </a:solidFill>
@@ -11716,10 +11771,10 @@
                 <a:ea typeface="Bricolage Grotesque ExtraBold" pitchFamily="34" charset="-122"/>
                 <a:cs typeface="Bricolage Grotesque ExtraBold" pitchFamily="34" charset="-120"/>
               </a:rPr>
-              <a:t>Swift,</a:t>
-            </a:r>
-            <a:r>
-              <a:rPr lang="en-US" sz="3000" dirty="0" spc="-12" kern="0">
+              <a:t>Ứng</a:t>
+            </a:r>
+            <a:r>
+              <a:rPr lang="en-US" sz="3000" dirty="0" spc="8" kern="0">
                 <a:solidFill>
                   <a:srgbClr val="14161C"/>
                 </a:solidFill>
@@ -11727,10 +11782,10 @@
                 <a:ea typeface="Bricolage Grotesque ExtraBold" pitchFamily="34" charset="-122"/>
                 <a:cs typeface="Bricolage Grotesque ExtraBold" pitchFamily="34" charset="-120"/>
               </a:rPr>
-              <a:t> Kotlin;</a:t>
-            </a:r>
-            <a:r>
-              <a:rPr lang="en-US" sz="3000" dirty="0" spc="-5" kern="0">
+              <a:t> dụng,</a:t>
+            </a:r>
+            <a:r>
+              <a:rPr lang="en-US" sz="3000" dirty="0" spc="-7" kern="0">
                 <a:solidFill>
                   <a:srgbClr val="14161C"/>
                 </a:solidFill>
@@ -11738,7 +11793,29 @@
                 <a:ea typeface="Bricolage Grotesque ExtraBold" pitchFamily="34" charset="-122"/>
                 <a:cs typeface="Bricolage Grotesque ExtraBold" pitchFamily="34" charset="-120"/>
               </a:rPr>
-              <a:t> GraphQL</a:t>
+              <a:t> Zuul,</a:t>
+            </a:r>
+            <a:r>
+              <a:rPr lang="en-US" sz="3000" dirty="0" spc="0" kern="0">
+                <a:solidFill>
+                  <a:srgbClr val="14161C"/>
+                </a:solidFill>
+                <a:latin typeface="Bricolage Grotesque ExtraBold" pitchFamily="34" charset="0"/>
+                <a:ea typeface="Bricolage Grotesque ExtraBold" pitchFamily="34" charset="-122"/>
+                <a:cs typeface="Bricolage Grotesque ExtraBold" pitchFamily="34" charset="-120"/>
+              </a:rPr>
+              <a:t> Open</a:t>
+            </a:r>
+            <a:r>
+              <a:rPr lang="en-US" sz="3000" dirty="0" spc="1" kern="0">
+                <a:solidFill>
+                  <a:srgbClr val="14161C"/>
+                </a:solidFill>
+                <a:latin typeface="Bricolage Grotesque ExtraBold" pitchFamily="34" charset="0"/>
+                <a:ea typeface="Bricolage Grotesque ExtraBold" pitchFamily="34" charset="-122"/>
+                <a:cs typeface="Bricolage Grotesque ExtraBold" pitchFamily="34" charset="-120"/>
+              </a:rPr>
+              <a:t> Connect</a:t>
             </a:r>
             <a:endParaRPr lang="en-US" sz="3000" dirty="0"/>
           </a:p>
@@ -11821,7 +11898,7 @@
               <a:buNone/>
             </a:pPr>
             <a:r>
-              <a:rPr lang="en-US" sz="1800" b="1" spc="227" kern="0" dirty="0">
+              <a:rPr lang="en-US" sz="1800" b="1" spc="228" kern="0" dirty="0">
                 <a:solidFill>
                   <a:srgbClr val="B45309"/>
                 </a:solidFill>
@@ -11829,10 +11906,10 @@
                 <a:ea typeface="Be Vietnam Pro" pitchFamily="34" charset="-122"/>
                 <a:cs typeface="Be Vietnam Pro" pitchFamily="34" charset="-120"/>
               </a:rPr>
-              <a:t>DỊCH</a:t>
-            </a:r>
-            <a:r>
-              <a:rPr lang="en-US" sz="1800" b="1" spc="229" kern="0" dirty="0">
+              <a:t>CÓ</a:t>
+            </a:r>
+            <a:r>
+              <a:rPr lang="en-US" sz="1800" b="1" spc="226" kern="0" dirty="0">
                 <a:solidFill>
                   <a:srgbClr val="B45309"/>
                 </a:solidFill>
@@ -11840,10 +11917,10 @@
                 <a:ea typeface="Be Vietnam Pro" pitchFamily="34" charset="-122"/>
                 <a:cs typeface="Be Vietnam Pro" pitchFamily="34" charset="-120"/>
               </a:rPr>
-              <a:t> VỤ</a:t>
-            </a:r>
-            <a:r>
-              <a:rPr lang="en-US" sz="1800" b="1" spc="225" kern="0" dirty="0">
+              <a:t> THỂ</a:t>
+            </a:r>
+            <a:r>
+              <a:rPr lang="en-US" sz="1800" b="1" spc="228" kern="0" dirty="0">
                 <a:solidFill>
                   <a:srgbClr val="B45309"/>
                 </a:solidFill>
@@ -11851,10 +11928,10 @@
                 <a:ea typeface="Be Vietnam Pro" pitchFamily="34" charset="-122"/>
                 <a:cs typeface="Be Vietnam Pro" pitchFamily="34" charset="-120"/>
               </a:rPr>
-              <a:t> ·</a:t>
-            </a:r>
-            <a:r>
-              <a:rPr lang="en-US" sz="1800" b="1" spc="228" kern="0" dirty="0">
+              <a:t> CHỈ</a:t>
+            </a:r>
+            <a:r>
+              <a:rPr lang="en-US" sz="1800" b="1" spc="226" kern="0" dirty="0">
                 <a:solidFill>
                   <a:srgbClr val="B45309"/>
                 </a:solidFill>
@@ -11862,18 +11939,7 @@
                 <a:ea typeface="Be Vietnam Pro" pitchFamily="34" charset="-122"/>
                 <a:cs typeface="Be Vietnam Pro" pitchFamily="34" charset="-120"/>
               </a:rPr>
-              <a:t> DỮ</a:t>
-            </a:r>
-            <a:r>
-              <a:rPr lang="en-US" sz="1800" b="1" spc="224" kern="0" dirty="0">
-                <a:solidFill>
-                  <a:srgbClr val="B45309"/>
-                </a:solidFill>
-                <a:latin typeface="Be Vietnam Pro" pitchFamily="34" charset="0"/>
-                <a:ea typeface="Be Vietnam Pro" pitchFamily="34" charset="-122"/>
-                <a:cs typeface="Be Vietnam Pro" pitchFamily="34" charset="-120"/>
-              </a:rPr>
-              <a:t> LIỆU</a:t>
+              <a:t> CHẬM</a:t>
             </a:r>
             <a:endParaRPr lang="en-US" sz="1800" dirty="0"/>
           </a:p>
@@ -11904,7 +11970,7 @@
               <a:buNone/>
             </a:pPr>
             <a:r>
-              <a:rPr lang="en-US" sz="3000" dirty="0" spc="-8" kern="0">
+              <a:rPr lang="en-US" sz="3000" dirty="0" spc="-13" kern="0">
                 <a:solidFill>
                   <a:srgbClr val="14161C"/>
                 </a:solidFill>
@@ -11912,10 +11978,10 @@
                 <a:ea typeface="Bricolage Grotesque ExtraBold" pitchFamily="34" charset="-122"/>
                 <a:cs typeface="Bricolage Grotesque ExtraBold" pitchFamily="34" charset="-120"/>
               </a:rPr>
-              <a:t>Zuul,</a:t>
-            </a:r>
-            <a:r>
-              <a:rPr lang="en-US" sz="3000" dirty="0" spc="-13" kern="0">
+              <a:t>EVCache,</a:t>
+            </a:r>
+            <a:r>
+              <a:rPr lang="en-US" sz="3000" dirty="0" spc="-1" kern="0">
                 <a:solidFill>
                   <a:srgbClr val="14161C"/>
                 </a:solidFill>
@@ -11923,10 +11989,10 @@
                 <a:ea typeface="Bricolage Grotesque ExtraBold" pitchFamily="34" charset="-122"/>
                 <a:cs typeface="Bricolage Grotesque ExtraBold" pitchFamily="34" charset="-120"/>
               </a:rPr>
-              <a:t> EVCache,</a:t>
-            </a:r>
-            <a:r>
-              <a:rPr lang="en-US" sz="3000" dirty="0" spc="-1" kern="0">
+              <a:t> nếu dữ</a:t>
+            </a:r>
+            <a:r>
+              <a:rPr lang="en-US" sz="3000" dirty="0" spc="1" kern="0">
                 <a:solidFill>
                   <a:srgbClr val="14161C"/>
                 </a:solidFill>
@@ -11934,7 +12000,29 @@
                 <a:ea typeface="Bricolage Grotesque ExtraBold" pitchFamily="34" charset="-122"/>
                 <a:cs typeface="Bricolage Grotesque ExtraBold" pitchFamily="34" charset="-120"/>
               </a:rPr>
-              <a:t> Cassandra</a:t>
+              <a:t> liệu</a:t>
+            </a:r>
+            <a:r>
+              <a:rPr lang="en-US" sz="3000" dirty="0" spc="-1" kern="0">
+                <a:solidFill>
+                  <a:srgbClr val="14161C"/>
+                </a:solidFill>
+                <a:latin typeface="Bricolage Grotesque ExtraBold" pitchFamily="34" charset="0"/>
+                <a:ea typeface="Bricolage Grotesque ExtraBold" pitchFamily="34" charset="-122"/>
+                <a:cs typeface="Bricolage Grotesque ExtraBold" pitchFamily="34" charset="-120"/>
+              </a:rPr>
+              <a:t> chịu</a:t>
+            </a:r>
+            <a:r>
+              <a:rPr lang="en-US" sz="3000" dirty="0" spc="0" kern="0">
+                <a:solidFill>
+                  <a:srgbClr val="14161C"/>
+                </a:solidFill>
+                <a:latin typeface="Bricolage Grotesque ExtraBold" pitchFamily="34" charset="0"/>
+                <a:ea typeface="Bricolage Grotesque ExtraBold" pitchFamily="34" charset="-122"/>
+                <a:cs typeface="Bricolage Grotesque ExtraBold" pitchFamily="34" charset="-120"/>
+              </a:rPr>
+              <a:t> nổi</a:t>
             </a:r>
             <a:endParaRPr lang="en-US" sz="3000" dirty="0"/>
           </a:p>
@@ -12012,7 +12100,7 @@
               <a:buNone/>
             </a:pPr>
             <a:r>
-              <a:rPr lang="en-US" sz="1800" b="1" spc="255" kern="0" dirty="0">
+              <a:rPr lang="en-US" sz="1800" b="1" spc="182" kern="0" dirty="0">
                 <a:solidFill>
                   <a:srgbClr val="B45309"/>
                 </a:solidFill>
@@ -12020,10 +12108,10 @@
                 <a:ea typeface="Be Vietnam Pro" pitchFamily="34" charset="-122"/>
                 <a:cs typeface="Be Vietnam Pro" pitchFamily="34" charset="-120"/>
               </a:rPr>
-              <a:t>LƯU</a:t>
-            </a:r>
-            <a:r>
-              <a:rPr lang="en-US" sz="1800" b="1" spc="223" kern="0" dirty="0">
+              <a:t>THẤY</a:t>
+            </a:r>
+            <a:r>
+              <a:rPr lang="en-US" sz="1800" b="1" spc="225" kern="0" dirty="0">
                 <a:solidFill>
                   <a:srgbClr val="B45309"/>
                 </a:solidFill>
@@ -12031,7 +12119,29 @@
                 <a:ea typeface="Be Vietnam Pro" pitchFamily="34" charset="-122"/>
                 <a:cs typeface="Be Vietnam Pro" pitchFamily="34" charset="-120"/>
               </a:rPr>
-              <a:t> VIDEO</a:t>
+              <a:t> MUỘN,</a:t>
+            </a:r>
+            <a:r>
+              <a:rPr lang="en-US" sz="1800" b="1" spc="201" kern="0" dirty="0">
+                <a:solidFill>
+                  <a:srgbClr val="B45309"/>
+                </a:solidFill>
+                <a:latin typeface="Be Vietnam Pro" pitchFamily="34" charset="0"/>
+                <a:ea typeface="Be Vietnam Pro" pitchFamily="34" charset="-122"/>
+                <a:cs typeface="Be Vietnam Pro" pitchFamily="34" charset="-120"/>
+              </a:rPr>
+              <a:t> HOẶC</a:t>
+            </a:r>
+            <a:r>
+              <a:rPr lang="en-US" sz="1800" b="1" spc="226" kern="0" dirty="0">
+                <a:solidFill>
+                  <a:srgbClr val="B45309"/>
+                </a:solidFill>
+                <a:latin typeface="Be Vietnam Pro" pitchFamily="34" charset="0"/>
+                <a:ea typeface="Be Vietnam Pro" pitchFamily="34" charset="-122"/>
+                <a:cs typeface="Be Vietnam Pro" pitchFamily="34" charset="-120"/>
+              </a:rPr>
+              <a:t> KHÔNG</a:t>
             </a:r>
             <a:endParaRPr lang="en-US" sz="1800" dirty="0"/>
           </a:p>
@@ -12062,7 +12172,7 @@
               <a:buNone/>
             </a:pPr>
             <a:r>
-              <a:rPr lang="en-US" sz="3000" dirty="0" spc="14" kern="0">
+              <a:rPr lang="en-US" sz="3000" dirty="0" spc="-9" kern="0">
                 <a:solidFill>
                   <a:srgbClr val="14161C"/>
                 </a:solidFill>
@@ -12070,10 +12180,10 @@
                 <a:ea typeface="Bricolage Grotesque ExtraBold" pitchFamily="34" charset="-122"/>
                 <a:cs typeface="Bricolage Grotesque ExtraBold" pitchFamily="34" charset="-120"/>
               </a:rPr>
-              <a:t>S3,</a:t>
-            </a:r>
-            <a:r>
-              <a:rPr lang="en-US" sz="3000" dirty="0" spc="0" kern="0">
+              <a:t>Kafka,</a:t>
+            </a:r>
+            <a:r>
+              <a:rPr lang="en-US" sz="3000" dirty="0" spc="3" kern="0">
                 <a:solidFill>
                   <a:srgbClr val="14161C"/>
                 </a:solidFill>
@@ -12081,10 +12191,10 @@
                 <a:ea typeface="Bricolage Grotesque ExtraBold" pitchFamily="34" charset="-122"/>
                 <a:cs typeface="Bricolage Grotesque ExtraBold" pitchFamily="34" charset="-120"/>
               </a:rPr>
-              <a:t> Open</a:t>
-            </a:r>
-            <a:r>
-              <a:rPr lang="en-US" sz="3000" dirty="0" spc="1" kern="0">
+              <a:t> Spark,</a:t>
+            </a:r>
+            <a:r>
+              <a:rPr lang="en-US" sz="3000" dirty="0" spc="-1" kern="0">
                 <a:solidFill>
                   <a:srgbClr val="14161C"/>
                 </a:solidFill>
@@ -12092,7 +12202,7 @@
                 <a:ea typeface="Bricolage Grotesque ExtraBold" pitchFamily="34" charset="-122"/>
                 <a:cs typeface="Bricolage Grotesque ExtraBold" pitchFamily="34" charset="-120"/>
               </a:rPr>
-              <a:t> Connect</a:t>
+              <a:t> Jenkins</a:t>
             </a:r>
             <a:endParaRPr lang="en-US" sz="3000" dirty="0"/>
           </a:p>
@@ -12148,6 +12258,39 @@
               <a:buNone/>
             </a:pPr>
             <a:r>
+              <a:rPr lang="en-US" sz="2100" dirty="0" spc="-32" kern="0">
+                <a:solidFill>
+                  <a:srgbClr val="6B6A66"/>
+                </a:solidFill>
+                <a:latin typeface="Be Vietnam Pro" pitchFamily="34" charset="0"/>
+                <a:ea typeface="Be Vietnam Pro" pitchFamily="34" charset="-122"/>
+                <a:cs typeface="Be Vietnam Pro" pitchFamily="34" charset="-120"/>
+              </a:rPr>
+              <a:t>Lập</a:t>
+            </a:r>
+            <a:r>
+              <a:rPr lang="en-US" sz="2100" dirty="0" spc="-1" kern="0">
+                <a:solidFill>
+                  <a:srgbClr val="6B6A66"/>
+                </a:solidFill>
+                <a:latin typeface="Be Vietnam Pro" pitchFamily="34" charset="0"/>
+                <a:ea typeface="Be Vietnam Pro" pitchFamily="34" charset="-122"/>
+                <a:cs typeface="Be Vietnam Pro" pitchFamily="34" charset="-120"/>
+              </a:rPr>
+              <a:t> luận của</a:t>
+            </a:r>
+            <a:r>
+              <a:rPr lang="en-US" sz="2100" dirty="0" spc="5" kern="0">
+                <a:solidFill>
+                  <a:srgbClr val="6B6A66"/>
+                </a:solidFill>
+                <a:latin typeface="Be Vietnam Pro" pitchFamily="34" charset="0"/>
+                <a:ea typeface="Be Vietnam Pro" pitchFamily="34" charset="-122"/>
+                <a:cs typeface="Be Vietnam Pro" pitchFamily="34" charset="-120"/>
+              </a:rPr>
+              <a:t> người</a:t>
+            </a:r>
+            <a:r>
               <a:rPr lang="en-US" sz="2100" dirty="0" spc="0" kern="0">
                 <a:solidFill>
                   <a:srgbClr val="6B6A66"/>
@@ -12156,7 +12299,18 @@
                 <a:ea typeface="Be Vietnam Pro" pitchFamily="34" charset="-122"/>
                 <a:cs typeface="Be Vietnam Pro" pitchFamily="34" charset="-120"/>
               </a:rPr>
-              <a:t>Nguồn</a:t>
+              <a:t> biên</a:t>
+            </a:r>
+            <a:r>
+              <a:rPr lang="en-US" sz="2100" dirty="0" spc="-6" kern="0">
+                <a:solidFill>
+                  <a:srgbClr val="6B6A66"/>
+                </a:solidFill>
+                <a:latin typeface="Be Vietnam Pro" pitchFamily="34" charset="0"/>
+                <a:ea typeface="Be Vietnam Pro" pitchFamily="34" charset="-122"/>
+                <a:cs typeface="Be Vietnam Pro" pitchFamily="34" charset="-120"/>
+              </a:rPr>
+              <a:t> soạn,</a:t>
             </a:r>
             <a:r>
               <a:rPr lang="en-US" sz="2100" dirty="0" spc="-1" kern="0">
@@ -12167,10 +12321,10 @@
                 <a:ea typeface="Be Vietnam Pro" pitchFamily="34" charset="-122"/>
                 <a:cs typeface="Be Vietnam Pro" pitchFamily="34" charset="-120"/>
               </a:rPr>
-              <a:t> không nói mảng nào</a:t>
-            </a:r>
-            <a:r>
-              <a:rPr lang="en-US" sz="2100" dirty="0" spc="-2" kern="0">
+              <a:t> không</a:t>
+            </a:r>
+            <a:r>
+              <a:rPr lang="en-US" sz="2100" dirty="0" spc="0" kern="0">
                 <a:solidFill>
                   <a:srgbClr val="6B6A66"/>
                 </a:solidFill>
@@ -12178,10 +12332,10 @@
                 <a:ea typeface="Be Vietnam Pro" pitchFamily="34" charset="-122"/>
                 <a:cs typeface="Be Vietnam Pro" pitchFamily="34" charset="-120"/>
               </a:rPr>
-              <a:t> phục</a:t>
-            </a:r>
-            <a:r>
-              <a:rPr lang="en-US" sz="2100" dirty="0" spc="-1" kern="0">
+              <a:t> từ</a:t>
+            </a:r>
+            <a:r>
+              <a:rPr lang="en-US" sz="2100" dirty="0" spc="-5" kern="0">
                 <a:solidFill>
                   <a:srgbClr val="6B6A66"/>
                 </a:solidFill>
@@ -12189,10 +12343,10 @@
                 <a:ea typeface="Be Vietnam Pro" pitchFamily="34" charset="-122"/>
                 <a:cs typeface="Be Vietnam Pro" pitchFamily="34" charset="-120"/>
               </a:rPr>
-              <a:t> vụ</a:t>
-            </a:r>
-            <a:r>
-              <a:rPr lang="en-US" sz="2100" dirty="0" spc="-8" kern="0">
+              <a:t> bài</a:t>
+            </a:r>
+            <a:r>
+              <a:rPr lang="en-US" sz="2100" dirty="0" spc="0" kern="0">
                 <a:solidFill>
                   <a:srgbClr val="6B6A66"/>
                 </a:solidFill>
@@ -12200,73 +12354,7 @@
                 <a:ea typeface="Be Vietnam Pro" pitchFamily="34" charset="-122"/>
                 <a:cs typeface="Be Vietnam Pro" pitchFamily="34" charset="-120"/>
               </a:rPr>
-              <a:t> một</a:t>
-            </a:r>
-            <a:r>
-              <a:rPr lang="en-US" sz="2100" dirty="0" spc="-1" kern="0">
-                <a:solidFill>
-                  <a:srgbClr val="6B6A66"/>
-                </a:solidFill>
-                <a:latin typeface="Be Vietnam Pro" pitchFamily="34" charset="0"/>
-                <a:ea typeface="Be Vietnam Pro" pitchFamily="34" charset="-122"/>
-                <a:cs typeface="Be Vietnam Pro" pitchFamily="34" charset="-120"/>
-              </a:rPr>
-              <a:t> lần</a:t>
-            </a:r>
-            <a:r>
-              <a:rPr lang="en-US" sz="2100" dirty="0" spc="-15" kern="0">
-                <a:solidFill>
-                  <a:srgbClr val="6B6A66"/>
-                </a:solidFill>
-                <a:latin typeface="Be Vietnam Pro" pitchFamily="34" charset="0"/>
-                <a:ea typeface="Be Vietnam Pro" pitchFamily="34" charset="-122"/>
-                <a:cs typeface="Be Vietnam Pro" pitchFamily="34" charset="-120"/>
-              </a:rPr>
-              <a:t> xem,</a:t>
-            </a:r>
-            <a:r>
-              <a:rPr lang="en-US" sz="2100" dirty="0" spc="-10" kern="0">
-                <a:solidFill>
-                  <a:srgbClr val="6B6A66"/>
-                </a:solidFill>
-                <a:latin typeface="Be Vietnam Pro" pitchFamily="34" charset="0"/>
-                <a:ea typeface="Be Vietnam Pro" pitchFamily="34" charset="-122"/>
-                <a:cs typeface="Be Vietnam Pro" pitchFamily="34" charset="-120"/>
-              </a:rPr>
-              <a:t> hay</a:t>
-            </a:r>
-            <a:r>
-              <a:rPr lang="en-US" sz="2100" dirty="0" spc="-5" kern="0">
-                <a:solidFill>
-                  <a:srgbClr val="6B6A66"/>
-                </a:solidFill>
-                <a:latin typeface="Be Vietnam Pro" pitchFamily="34" charset="0"/>
-                <a:ea typeface="Be Vietnam Pro" pitchFamily="34" charset="-122"/>
-                <a:cs typeface="Be Vietnam Pro" pitchFamily="34" charset="-120"/>
-              </a:rPr>
-              <a:t> theo</a:t>
-            </a:r>
-            <a:r>
-              <a:rPr lang="en-US" sz="2100" dirty="0" spc="0" kern="0">
-                <a:solidFill>
-                  <a:srgbClr val="6B6A66"/>
-                </a:solidFill>
-                <a:latin typeface="Be Vietnam Pro" pitchFamily="34" charset="0"/>
-                <a:ea typeface="Be Vietnam Pro" pitchFamily="34" charset="-122"/>
-                <a:cs typeface="Be Vietnam Pro" pitchFamily="34" charset="-120"/>
-              </a:rPr>
-              <a:t> thứ</a:t>
-            </a:r>
-            <a:r>
-              <a:rPr lang="en-US" sz="2100" dirty="0" spc="-1" kern="0">
-                <a:solidFill>
-                  <a:srgbClr val="6B6A66"/>
-                </a:solidFill>
-                <a:latin typeface="Be Vietnam Pro" pitchFamily="34" charset="0"/>
-                <a:ea typeface="Be Vietnam Pro" pitchFamily="34" charset="-122"/>
-                <a:cs typeface="Be Vietnam Pro" pitchFamily="34" charset="-120"/>
-              </a:rPr>
-              <a:t> tự nào.</a:t>
+              <a:t> nguồn.</a:t>
             </a:r>
             <a:endParaRPr lang="en-US" sz="2100" dirty="0"/>
           </a:p>
@@ -12738,7 +12826,7 @@
               <a:buNone/>
             </a:pPr>
             <a:r>
-              <a:rPr lang="en-US" sz="1950" b="1" spc="299" kern="0" dirty="0">
+              <a:rPr lang="en-US" sz="1950" b="1" spc="302" kern="0" dirty="0">
                 <a:solidFill>
                   <a:srgbClr val="3DD6A0"/>
                 </a:solidFill>
@@ -12746,10 +12834,10 @@
                 <a:ea typeface="Be Vietnam Pro" pitchFamily="34" charset="-122"/>
                 <a:cs typeface="Be Vietnam Pro" pitchFamily="34" charset="-120"/>
               </a:rPr>
-              <a:t>XEM</a:t>
-            </a:r>
-            <a:r>
-              <a:rPr lang="en-US" sz="1950" b="1" spc="287" kern="0" dirty="0">
+              <a:t>THỬ</a:t>
+            </a:r>
+            <a:r>
+              <a:rPr lang="en-US" sz="1950" b="1" spc="301" kern="0" dirty="0">
                 <a:solidFill>
                   <a:srgbClr val="3DD6A0"/>
                 </a:solidFill>
@@ -12757,10 +12845,10 @@
                 <a:ea typeface="Be Vietnam Pro" pitchFamily="34" charset="-122"/>
                 <a:cs typeface="Be Vietnam Pro" pitchFamily="34" charset="-120"/>
               </a:rPr>
-              <a:t> SÂU</a:t>
-            </a:r>
-            <a:r>
-              <a:rPr lang="en-US" sz="1950" b="1" spc="300" kern="0" dirty="0">
+              <a:t> LẬP</a:t>
+            </a:r>
+            <a:r>
+              <a:rPr lang="en-US" sz="1950" b="1" spc="291" kern="0" dirty="0">
                 <a:solidFill>
                   <a:srgbClr val="3DD6A0"/>
                 </a:solidFill>
@@ -12768,7 +12856,7 @@
                 <a:ea typeface="Be Vietnam Pro" pitchFamily="34" charset="-122"/>
                 <a:cs typeface="Be Vietnam Pro" pitchFamily="34" charset="-120"/>
               </a:rPr>
-              <a:t> HƠN</a:t>
+              <a:t> LUẬN</a:t>
             </a:r>
             <a:endParaRPr lang="en-US" sz="1950" dirty="0"/>
           </a:p>
@@ -12802,7 +12890,7 @@
               <a:buNone/>
             </a:pPr>
             <a:r>
-              <a:rPr lang="en-US" sz="6900" dirty="0" spc="-2" kern="0">
+              <a:rPr lang="en-US" sz="6900" dirty="0" spc="-4" kern="0">
                 <a:solidFill>
                   <a:srgbClr val="F3EEE3"/>
                 </a:solidFill>
@@ -12810,10 +12898,10 @@
                 <a:ea typeface="Bricolage Grotesque ExtraBold" pitchFamily="34" charset="-122"/>
                 <a:cs typeface="Bricolage Grotesque ExtraBold" pitchFamily="34" charset="-120"/>
               </a:rPr>
-              <a:t>Hai</a:t>
-            </a:r>
-            <a:r>
-              <a:rPr lang="en-US" sz="6900" dirty="0" spc="0" kern="0">
+              <a:t>Ba</a:t>
+            </a:r>
+            <a:r>
+              <a:rPr lang="en-US" sz="6900" dirty="0" spc="-2" kern="0">
                 <a:solidFill>
                   <a:srgbClr val="F3EEE3"/>
                 </a:solidFill>
@@ -12821,10 +12909,10 @@
                 <a:ea typeface="Bricolage Grotesque ExtraBold" pitchFamily="34" charset="-122"/>
                 <a:cs typeface="Bricolage Grotesque ExtraBold" pitchFamily="34" charset="-120"/>
               </a:rPr>
-              <a:t> cái</a:t>
-            </a:r>
-            <a:r>
-              <a:rPr lang="en-US" sz="6900" dirty="0" spc="-18" kern="0">
+              <a:t> cơ</a:t>
+            </a:r>
+            <a:r>
+              <a:rPr lang="en-US" sz="6900" dirty="0" spc="1" kern="0">
                 <a:solidFill>
                   <a:srgbClr val="F3EEE3"/>
                 </a:solidFill>
@@ -12832,10 +12920,10 @@
                 <a:ea typeface="Bricolage Grotesque ExtraBold" pitchFamily="34" charset="-122"/>
                 <a:cs typeface="Bricolage Grotesque ExtraBold" pitchFamily="34" charset="-120"/>
               </a:rPr>
-              <a:t> tên</a:t>
-            </a:r>
-            <a:r>
-              <a:rPr lang="en-US" sz="6900" dirty="0" spc="7" kern="0">
+              <a:t> sở</a:t>
+            </a:r>
+            <a:r>
+              <a:rPr lang="en-US" sz="6900" dirty="0" spc="-1" kern="0">
                 <a:solidFill>
                   <a:srgbClr val="F3EEE3"/>
                 </a:solidFill>
@@ -12843,10 +12931,10 @@
                 <a:ea typeface="Bricolage Grotesque ExtraBold" pitchFamily="34" charset="-122"/>
                 <a:cs typeface="Bricolage Grotesque ExtraBold" pitchFamily="34" charset="-120"/>
               </a:rPr>
-              <a:t> đáng</a:t>
-            </a:r>
-            <a:r>
-              <a:rPr lang="en-US" sz="6900" dirty="0" spc="2" kern="0">
+              <a:t> dữ</a:t>
+            </a:r>
+            <a:r>
+              <a:rPr lang="en-US" sz="6900" dirty="0" spc="3" kern="0">
                 <a:solidFill>
                   <a:srgbClr val="F3EEE3"/>
                 </a:solidFill>
@@ -12854,7 +12942,40 @@
                 <a:ea typeface="Bricolage Grotesque ExtraBold" pitchFamily="34" charset="-122"/>
                 <a:cs typeface="Bricolage Grotesque ExtraBold" pitchFamily="34" charset="-120"/>
               </a:rPr>
-              <a:t> nhớ</a:t>
+              <a:t> liệu,</a:t>
+            </a:r>
+            <a:r>
+              <a:rPr lang="en-US" sz="6900" dirty="0" spc="-6" kern="0">
+                <a:solidFill>
+                  <a:srgbClr val="F3EEE3"/>
+                </a:solidFill>
+                <a:latin typeface="Bricolage Grotesque ExtraBold" pitchFamily="34" charset="0"/>
+                <a:ea typeface="Bricolage Grotesque ExtraBold" pitchFamily="34" charset="-122"/>
+                <a:cs typeface="Bricolage Grotesque ExtraBold" pitchFamily="34" charset="-120"/>
+              </a:rPr>
+              <a:t> ba</a:t>
+            </a:r>
+            <a:r>
+              <a:rPr lang="en-US" sz="6900" dirty="0" spc="1" kern="0">
+                <a:solidFill>
+                  <a:srgbClr val="F3EEE3"/>
+                </a:solidFill>
+                <a:latin typeface="Bricolage Grotesque ExtraBold" pitchFamily="34" charset="0"/>
+                <a:ea typeface="Bricolage Grotesque ExtraBold" pitchFamily="34" charset="-122"/>
+                <a:cs typeface="Bricolage Grotesque ExtraBold" pitchFamily="34" charset="-120"/>
+              </a:rPr>
+              <a:t> ưu</a:t>
+            </a:r>
+            <a:r>
+              <a:rPr lang="en-US" sz="6900" dirty="0" spc="5" kern="0">
+                <a:solidFill>
+                  <a:srgbClr val="F3EEE3"/>
+                </a:solidFill>
+                <a:latin typeface="Bricolage Grotesque ExtraBold" pitchFamily="34" charset="0"/>
+                <a:ea typeface="Bricolage Grotesque ExtraBold" pitchFamily="34" charset="-122"/>
+                <a:cs typeface="Bricolage Grotesque ExtraBold" pitchFamily="34" charset="-120"/>
+              </a:rPr>
+              <a:t> tiên</a:t>
             </a:r>
             <a:endParaRPr lang="en-US" sz="6900" dirty="0"/>
           </a:p>
@@ -12951,6 +13072,17 @@
               <a:buNone/>
             </a:pPr>
             <a:r>
+              <a:rPr lang="en-US" sz="2700" dirty="0" spc="-5" kern="0">
+                <a:solidFill>
+                  <a:srgbClr val="E4E1D8"/>
+                </a:solidFill>
+                <a:latin typeface="Be Vietnam Pro" pitchFamily="34" charset="0"/>
+                <a:ea typeface="Be Vietnam Pro" pitchFamily="34" charset="-122"/>
+                <a:cs typeface="Be Vietnam Pro" pitchFamily="34" charset="-120"/>
+              </a:rPr>
+              <a:t>EVCache:</a:t>
+            </a:r>
+            <a:r>
               <a:rPr lang="en-US" sz="2700" dirty="0" spc="-2" kern="0">
                 <a:solidFill>
                   <a:srgbClr val="E4E1D8"/>
@@ -12959,7 +13091,18 @@
                 <a:ea typeface="Be Vietnam Pro" pitchFamily="34" charset="-122"/>
                 <a:cs typeface="Be Vietnam Pro" pitchFamily="34" charset="-120"/>
               </a:rPr>
-              <a:t>Open</a:t>
+              <a:t> nhanh,</a:t>
+            </a:r>
+            <a:r>
+              <a:rPr lang="en-US" sz="2700" dirty="0" spc="-13" kern="0">
+                <a:solidFill>
+                  <a:srgbClr val="E4E1D8"/>
+                </a:solidFill>
+                <a:latin typeface="Be Vietnam Pro" pitchFamily="34" charset="0"/>
+                <a:ea typeface="Be Vietnam Pro" pitchFamily="34" charset="-122"/>
+                <a:cs typeface="Be Vietnam Pro" pitchFamily="34" charset="-120"/>
+              </a:rPr>
+              <a:t> mất</a:t>
             </a:r>
             <a:r>
               <a:rPr lang="en-US" sz="2700" dirty="0" spc="-1" kern="0">
@@ -12970,10 +13113,10 @@
                 <a:ea typeface="Be Vietnam Pro" pitchFamily="34" charset="-122"/>
                 <a:cs typeface="Be Vietnam Pro" pitchFamily="34" charset="-120"/>
               </a:rPr>
-              <a:t> Connect:</a:t>
-            </a:r>
-            <a:r>
-              <a:rPr lang="en-US" sz="2700" dirty="0" spc="-12" kern="0">
+              <a:t> thì</a:t>
+            </a:r>
+            <a:r>
+              <a:rPr lang="en-US" sz="2700" dirty="0" spc="-2" kern="0">
                 <a:solidFill>
                   <a:srgbClr val="E4E1D8"/>
                 </a:solidFill>
@@ -12981,7 +13124,7 @@
                 <a:ea typeface="Be Vietnam Pro" pitchFamily="34" charset="-122"/>
                 <a:cs typeface="Be Vietnam Pro" pitchFamily="34" charset="-120"/>
               </a:rPr>
-              <a:t> máy</a:t>
+              <a:t> nạp</a:t>
             </a:r>
             <a:r>
               <a:rPr lang="en-US" sz="2700" dirty="0" spc="-1" kern="0">
@@ -12992,40 +13135,7 @@
                 <a:ea typeface="Be Vietnam Pro" pitchFamily="34" charset="-122"/>
                 <a:cs typeface="Be Vietnam Pro" pitchFamily="34" charset="-120"/>
               </a:rPr>
-              <a:t> chủ</a:t>
-            </a:r>
-            <a:r>
-              <a:rPr lang="en-US" sz="2700" dirty="0" spc="1" kern="0">
-                <a:solidFill>
-                  <a:srgbClr val="E4E1D8"/>
-                </a:solidFill>
-                <a:latin typeface="Be Vietnam Pro" pitchFamily="34" charset="0"/>
-                <a:ea typeface="Be Vietnam Pro" pitchFamily="34" charset="-122"/>
-                <a:cs typeface="Be Vietnam Pro" pitchFamily="34" charset="-120"/>
-              </a:rPr>
-              <a:t> đặt</a:t>
-            </a:r>
-            <a:r>
-              <a:rPr lang="en-US" sz="2700" dirty="0" spc="-16" kern="0">
-                <a:solidFill>
-                  <a:srgbClr val="E4E1D8"/>
-                </a:solidFill>
-                <a:latin typeface="Be Vietnam Pro" pitchFamily="34" charset="0"/>
-                <a:ea typeface="Be Vietnam Pro" pitchFamily="34" charset="-122"/>
-                <a:cs typeface="Be Vietnam Pro" pitchFamily="34" charset="-120"/>
-              </a:rPr>
-              <a:t> gần</a:t>
-            </a:r>
-            <a:r>
-              <a:rPr lang="en-US" sz="2700" dirty="0" spc="-2" kern="0">
-                <a:solidFill>
-                  <a:srgbClr val="E4E1D8"/>
-                </a:solidFill>
-                <a:latin typeface="Be Vietnam Pro" pitchFamily="34" charset="0"/>
-                <a:ea typeface="Be Vietnam Pro" pitchFamily="34" charset="-122"/>
-                <a:cs typeface="Be Vietnam Pro" pitchFamily="34" charset="-120"/>
-              </a:rPr>
-              <a:t> nhà mạng.</a:t>
+              <a:t> lại.</a:t>
             </a:r>
             <a:endParaRPr lang="en-US" sz="2700" dirty="0"/>
           </a:p>
@@ -13122,6 +13232,17 @@
               <a:buNone/>
             </a:pPr>
             <a:r>
+              <a:rPr lang="en-US" sz="2700" dirty="0" spc="-16" kern="0">
+                <a:solidFill>
+                  <a:srgbClr val="E4E1D8"/>
+                </a:solidFill>
+                <a:latin typeface="Be Vietnam Pro" pitchFamily="34" charset="0"/>
+                <a:ea typeface="Be Vietnam Pro" pitchFamily="34" charset="-122"/>
+                <a:cs typeface="Be Vietnam Pro" pitchFamily="34" charset="-120"/>
+              </a:rPr>
+              <a:t>Cassandra:</a:t>
+            </a:r>
+            <a:r>
               <a:rPr lang="en-US" sz="2700" dirty="0" spc="-2" kern="0">
                 <a:solidFill>
                   <a:srgbClr val="E4E1D8"/>
@@ -13130,10 +13251,10 @@
                 <a:ea typeface="Be Vietnam Pro" pitchFamily="34" charset="-122"/>
                 <a:cs typeface="Be Vietnam Pro" pitchFamily="34" charset="-120"/>
               </a:rPr>
-              <a:t>Chaos</a:t>
-            </a:r>
-            <a:r>
-              <a:rPr lang="en-US" sz="2700" dirty="0" spc="-28" kern="0">
+              <a:t> ghi</a:t>
+            </a:r>
+            <a:r>
+              <a:rPr lang="en-US" sz="2700" dirty="0" spc="0" kern="0">
                 <a:solidFill>
                   <a:srgbClr val="E4E1D8"/>
                 </a:solidFill>
@@ -13141,10 +13262,10 @@
                 <a:ea typeface="Be Vietnam Pro" pitchFamily="34" charset="-122"/>
                 <a:cs typeface="Be Vietnam Pro" pitchFamily="34" charset="-120"/>
               </a:rPr>
-              <a:t> Monkey:</a:t>
-            </a:r>
-            <a:r>
-              <a:rPr lang="en-US" sz="2700" dirty="0" spc="0" kern="0">
+              <a:t> nhiều,</a:t>
+            </a:r>
+            <a:r>
+              <a:rPr lang="en-US" sz="2700" dirty="0" spc="-1" kern="0">
                 <a:solidFill>
                   <a:srgbClr val="E4E1D8"/>
                 </a:solidFill>
@@ -13152,10 +13273,10 @@
                 <a:ea typeface="Be Vietnam Pro" pitchFamily="34" charset="-122"/>
                 <a:cs typeface="Be Vietnam Pro" pitchFamily="34" charset="-120"/>
               </a:rPr>
-              <a:t> cố</a:t>
-            </a:r>
-            <a:r>
-              <a:rPr lang="en-US" sz="2700" dirty="0" spc="-2" kern="0">
+              <a:t> chịu</a:t>
+            </a:r>
+            <a:r>
+              <a:rPr lang="en-US" sz="2700" dirty="0" spc="-13" kern="0">
                 <a:solidFill>
                   <a:srgbClr val="E4E1D8"/>
                 </a:solidFill>
@@ -13163,10 +13284,10 @@
                 <a:ea typeface="Be Vietnam Pro" pitchFamily="34" charset="-122"/>
                 <a:cs typeface="Be Vietnam Pro" pitchFamily="34" charset="-120"/>
               </a:rPr>
-              <a:t> ý</a:t>
-            </a:r>
-            <a:r>
-              <a:rPr lang="en-US" sz="2700" dirty="0" spc="-25" kern="0">
+              <a:t> vài</a:t>
+            </a:r>
+            <a:r>
+              <a:rPr lang="en-US" sz="2700" dirty="0" spc="-11" kern="0">
                 <a:solidFill>
                   <a:srgbClr val="E4E1D8"/>
                 </a:solidFill>
@@ -13174,10 +13295,10 @@
                 <a:ea typeface="Be Vietnam Pro" pitchFamily="34" charset="-122"/>
                 <a:cs typeface="Be Vietnam Pro" pitchFamily="34" charset="-120"/>
               </a:rPr>
-              <a:t> tắt</a:t>
-            </a:r>
-            <a:r>
-              <a:rPr lang="en-US" sz="2700" dirty="0" spc="-12" kern="0">
+              <a:t> máy</a:t>
+            </a:r>
+            <a:r>
+              <a:rPr lang="en-US" sz="2700" dirty="0" spc="-3" kern="0">
                 <a:solidFill>
                   <a:srgbClr val="E4E1D8"/>
                 </a:solidFill>
@@ -13185,29 +13306,7 @@
                 <a:ea typeface="Be Vietnam Pro" pitchFamily="34" charset="-122"/>
                 <a:cs typeface="Be Vietnam Pro" pitchFamily="34" charset="-120"/>
               </a:rPr>
-              <a:t> máy</a:t>
-            </a:r>
-            <a:r>
-              <a:rPr lang="en-US" sz="2700" dirty="0" spc="9" kern="0">
-                <a:solidFill>
-                  <a:srgbClr val="E4E1D8"/>
-                </a:solidFill>
-                <a:latin typeface="Be Vietnam Pro" pitchFamily="34" charset="0"/>
-                <a:ea typeface="Be Vietnam Pro" pitchFamily="34" charset="-122"/>
-                <a:cs typeface="Be Vietnam Pro" pitchFamily="34" charset="-120"/>
-              </a:rPr>
-              <a:t> đang</a:t>
-            </a:r>
-            <a:r>
-              <a:rPr lang="en-US" sz="2700" dirty="0" spc="-8" kern="0">
-                <a:solidFill>
-                  <a:srgbClr val="E4E1D8"/>
-                </a:solidFill>
-                <a:latin typeface="Be Vietnam Pro" pitchFamily="34" charset="0"/>
-                <a:ea typeface="Be Vietnam Pro" pitchFamily="34" charset="-122"/>
-                <a:cs typeface="Be Vietnam Pro" pitchFamily="34" charset="-120"/>
-              </a:rPr>
-              <a:t> chạy.</a:t>
+              <a:t> hỏng.</a:t>
             </a:r>
             <a:endParaRPr lang="en-US" sz="2700" dirty="0"/>
           </a:p>
@@ -13299,7 +13398,7 @@
               <a:buNone/>
             </a:pPr>
             <a:r>
-              <a:rPr lang="en-US" sz="2700" dirty="0" spc="3" kern="0">
+              <a:rPr lang="en-US" sz="2700" dirty="0" spc="-12" kern="0">
                 <a:solidFill>
                   <a:srgbClr val="14161C"/>
                 </a:solidFill>
@@ -13307,7 +13406,29 @@
                 <a:ea typeface="Be Vietnam Pro" pitchFamily="34" charset="-122"/>
                 <a:cs typeface="Be Vietnam Pro" pitchFamily="34" charset="-120"/>
               </a:rPr>
-              <a:t>Cả</a:t>
+              <a:t>CockroachDB:</a:t>
+            </a:r>
+            <a:r>
+              <a:rPr lang="en-US" sz="2700" dirty="0" spc="-11" kern="0">
+                <a:solidFill>
+                  <a:srgbClr val="14161C"/>
+                </a:solidFill>
+                <a:latin typeface="Be Vietnam Pro" pitchFamily="34" charset="0"/>
+                <a:ea typeface="Be Vietnam Pro" pitchFamily="34" charset="-122"/>
+                <a:cs typeface="Be Vietnam Pro" pitchFamily="34" charset="-120"/>
+              </a:rPr>
+              <a:t> nhất</a:t>
+            </a:r>
+            <a:r>
+              <a:rPr lang="en-US" sz="2700" dirty="0" spc="0" kern="0">
+                <a:solidFill>
+                  <a:srgbClr val="14161C"/>
+                </a:solidFill>
+                <a:latin typeface="Be Vietnam Pro" pitchFamily="34" charset="0"/>
+                <a:ea typeface="Be Vietnam Pro" pitchFamily="34" charset="-122"/>
+                <a:cs typeface="Be Vietnam Pro" pitchFamily="34" charset="-120"/>
+              </a:rPr>
+              <a:t> quán,</a:t>
             </a:r>
             <a:r>
               <a:rPr lang="en-US" sz="2700" dirty="0" spc="-2" kern="0">
@@ -13318,10 +13439,10 @@
                 <a:ea typeface="Be Vietnam Pro" pitchFamily="34" charset="-122"/>
                 <a:cs typeface="Be Vietnam Pro" pitchFamily="34" charset="-120"/>
               </a:rPr>
-              <a:t> hai:</a:t>
-            </a:r>
-            <a:r>
-              <a:rPr lang="en-US" sz="2700" dirty="0" spc="-5" kern="0">
+              <a:t> không</a:t>
+            </a:r>
+            <a:r>
+              <a:rPr lang="en-US" sz="2700" dirty="0" spc="9" kern="0">
                 <a:solidFill>
                   <a:srgbClr val="14161C"/>
                 </a:solidFill>
@@ -13329,10 +13450,10 @@
                 <a:ea typeface="Be Vietnam Pro" pitchFamily="34" charset="-122"/>
                 <a:cs typeface="Be Vietnam Pro" pitchFamily="34" charset="-120"/>
               </a:rPr>
-              <a:t> thiết</a:t>
-            </a:r>
-            <a:r>
-              <a:rPr lang="en-US" sz="2700" dirty="0" spc="-44" kern="0">
+              <a:t> được</a:t>
+            </a:r>
+            <a:r>
+              <a:rPr lang="en-US" sz="2700" dirty="0" spc="-8" kern="0">
                 <a:solidFill>
                   <a:srgbClr val="14161C"/>
                 </a:solidFill>
@@ -13340,51 +13461,7 @@
                 <a:ea typeface="Be Vietnam Pro" pitchFamily="34" charset="-122"/>
                 <a:cs typeface="Be Vietnam Pro" pitchFamily="34" charset="-120"/>
               </a:rPr>
-              <a:t> kế</a:t>
-            </a:r>
-            <a:r>
-              <a:rPr lang="en-US" sz="2700" dirty="0" spc="-9" kern="0">
-                <a:solidFill>
-                  <a:srgbClr val="14161C"/>
-                </a:solidFill>
-                <a:latin typeface="Be Vietnam Pro" pitchFamily="34" charset="0"/>
-                <a:ea typeface="Be Vietnam Pro" pitchFamily="34" charset="-122"/>
-                <a:cs typeface="Be Vietnam Pro" pitchFamily="34" charset="-120"/>
-              </a:rPr>
-              <a:t> sẵn</a:t>
-            </a:r>
-            <a:r>
-              <a:rPr lang="en-US" sz="2700" dirty="0" spc="-1" kern="0">
-                <a:solidFill>
-                  <a:srgbClr val="14161C"/>
-                </a:solidFill>
-                <a:latin typeface="Be Vietnam Pro" pitchFamily="34" charset="0"/>
-                <a:ea typeface="Be Vietnam Pro" pitchFamily="34" charset="-122"/>
-                <a:cs typeface="Be Vietnam Pro" pitchFamily="34" charset="-120"/>
-              </a:rPr>
-              <a:t> cho</a:t>
-            </a:r>
-            <a:r>
-              <a:rPr lang="en-US" sz="2700" dirty="0" spc="-2" kern="0">
-                <a:solidFill>
-                  <a:srgbClr val="14161C"/>
-                </a:solidFill>
-                <a:latin typeface="Be Vietnam Pro" pitchFamily="34" charset="0"/>
-                <a:ea typeface="Be Vietnam Pro" pitchFamily="34" charset="-122"/>
-                <a:cs typeface="Be Vietnam Pro" pitchFamily="34" charset="-120"/>
-              </a:rPr>
-              <a:t> hỏng</a:t>
-            </a:r>
-            <a:r>
-              <a:rPr lang="en-US" sz="2700" dirty="0" spc="-4" kern="0">
-                <a:solidFill>
-                  <a:srgbClr val="14161C"/>
-                </a:solidFill>
-                <a:latin typeface="Be Vietnam Pro" pitchFamily="34" charset="0"/>
-                <a:ea typeface="Be Vietnam Pro" pitchFamily="34" charset="-122"/>
-                <a:cs typeface="Be Vietnam Pro" pitchFamily="34" charset="-120"/>
-              </a:rPr>
-              <a:t> hóc.</a:t>
+              <a:t> sai.</a:t>
             </a:r>
             <a:endParaRPr lang="en-US" sz="2700" dirty="0"/>
           </a:p>

</xml_diff>